<commit_message>
update pagina ia site
</commit_message>
<xml_diff>
--- a/docs/ficheiros/apresentacao.pptx
+++ b/docs/ficheiros/apresentacao.pptx
@@ -509,10 +509,25 @@
   <pc:docChgLst>
     <pc:chgData name="Gabriela Gonçalves Carneiro" userId="d552a4f0-38ab-4544-a7a4-6025654d07bb" providerId="ADAL" clId="{D03F746D-BE5D-4789-93E6-42C6E52F57A2}"/>
     <pc:docChg chg="undo custSel addSld delSld modSld">
-      <pc:chgData name="Gabriela Gonçalves Carneiro" userId="d552a4f0-38ab-4544-a7a4-6025654d07bb" providerId="ADAL" clId="{D03F746D-BE5D-4789-93E6-42C6E52F57A2}" dt="2026-05-14T08:17:00.147" v="283" actId="20577"/>
+      <pc:chgData name="Gabriela Gonçalves Carneiro" userId="d552a4f0-38ab-4544-a7a4-6025654d07bb" providerId="ADAL" clId="{D03F746D-BE5D-4789-93E6-42C6E52F57A2}" dt="2026-05-14T12:39:32.351" v="286" actId="20577"/>
       <pc:docMkLst>
         <pc:docMk/>
       </pc:docMkLst>
+      <pc:sldChg chg="modSp mod">
+        <pc:chgData name="Gabriela Gonçalves Carneiro" userId="d552a4f0-38ab-4544-a7a4-6025654d07bb" providerId="ADAL" clId="{D03F746D-BE5D-4789-93E6-42C6E52F57A2}" dt="2026-05-14T12:39:32.351" v="286" actId="20577"/>
+        <pc:sldMkLst>
+          <pc:docMk/>
+          <pc:sldMk cId="0" sldId="259"/>
+        </pc:sldMkLst>
+        <pc:spChg chg="mod">
+          <ac:chgData name="Gabriela Gonçalves Carneiro" userId="d552a4f0-38ab-4544-a7a4-6025654d07bb" providerId="ADAL" clId="{D03F746D-BE5D-4789-93E6-42C6E52F57A2}" dt="2026-05-14T12:39:32.351" v="286" actId="20577"/>
+          <ac:spMkLst>
+            <pc:docMk/>
+            <pc:sldMk cId="0" sldId="259"/>
+            <ac:spMk id="14" creationId="{00000000-0000-0000-0000-000000000000}"/>
+          </ac:spMkLst>
+        </pc:spChg>
+      </pc:sldChg>
       <pc:sldChg chg="del">
         <pc:chgData name="Gabriela Gonçalves Carneiro" userId="d552a4f0-38ab-4544-a7a4-6025654d07bb" providerId="ADAL" clId="{D03F746D-BE5D-4789-93E6-42C6E52F57A2}" dt="2026-05-14T07:46:54.137" v="0" actId="47"/>
         <pc:sldMkLst>
@@ -6693,7 +6708,7 @@
               <a:t>Link do </a:t>
             </a:r>
             <a:r>
-              <a:rPr lang="en-US" sz="5500">
+              <a:rPr lang="en-US" sz="5500" dirty="0" err="1">
                 <a:solidFill>
                   <a:srgbClr val="000000"/>
                 </a:solidFill>
@@ -11325,223 +11340,7 @@
                 <a:cs typeface="Calibri (MS)"/>
                 <a:sym typeface="Calibri (MS)"/>
               </a:rPr>
-              <a:t> 1:1. O </a:t>
-            </a:r>
-            <a:r>
-              <a:rPr lang="en-US" sz="2499" dirty="0" err="1">
-                <a:solidFill>
-                  <a:srgbClr val="000000"/>
-                </a:solidFill>
-                <a:latin typeface="Calibri (MS)"/>
-                <a:ea typeface="Calibri (MS)"/>
-                <a:cs typeface="Calibri (MS)"/>
-                <a:sym typeface="Calibri (MS)"/>
-              </a:rPr>
-              <a:t>grupo</a:t>
-            </a:r>
-            <a:r>
-              <a:rPr lang="en-US" sz="2499" dirty="0">
-                <a:solidFill>
-                  <a:srgbClr val="000000"/>
-                </a:solidFill>
-                <a:latin typeface="Calibri (MS)"/>
-                <a:ea typeface="Calibri (MS)"/>
-                <a:cs typeface="Calibri (MS)"/>
-                <a:sym typeface="Calibri (MS)"/>
-              </a:rPr>
-              <a:t> </a:t>
-            </a:r>
-            <a:r>
-              <a:rPr lang="en-US" sz="2499" dirty="0" err="1">
-                <a:solidFill>
-                  <a:srgbClr val="000000"/>
-                </a:solidFill>
-                <a:latin typeface="Calibri (MS)"/>
-                <a:ea typeface="Calibri (MS)"/>
-                <a:cs typeface="Calibri (MS)"/>
-                <a:sym typeface="Calibri (MS)"/>
-              </a:rPr>
-              <a:t>intervenção</a:t>
-            </a:r>
-            <a:r>
-              <a:rPr lang="en-US" sz="2499" dirty="0">
-                <a:solidFill>
-                  <a:srgbClr val="000000"/>
-                </a:solidFill>
-                <a:latin typeface="Calibri (MS)"/>
-                <a:ea typeface="Calibri (MS)"/>
-                <a:cs typeface="Calibri (MS)"/>
-                <a:sym typeface="Calibri (MS)"/>
-              </a:rPr>
-              <a:t> </a:t>
-            </a:r>
-            <a:r>
-              <a:rPr lang="en-US" sz="2499" dirty="0" err="1">
-                <a:solidFill>
-                  <a:srgbClr val="000000"/>
-                </a:solidFill>
-                <a:latin typeface="Calibri (MS)"/>
-                <a:ea typeface="Calibri (MS)"/>
-                <a:cs typeface="Calibri (MS)"/>
-                <a:sym typeface="Calibri (MS)"/>
-              </a:rPr>
-              <a:t>utiliza</a:t>
-            </a:r>
-            <a:r>
-              <a:rPr lang="en-US" sz="2499" dirty="0">
-                <a:solidFill>
-                  <a:srgbClr val="000000"/>
-                </a:solidFill>
-                <a:latin typeface="Calibri (MS)"/>
-                <a:ea typeface="Calibri (MS)"/>
-                <a:cs typeface="Calibri (MS)"/>
-                <a:sym typeface="Calibri (MS)"/>
-              </a:rPr>
-              <a:t> a </a:t>
-            </a:r>
-            <a:r>
-              <a:rPr lang="en-US" sz="2499" dirty="0" err="1">
-                <a:solidFill>
-                  <a:srgbClr val="000000"/>
-                </a:solidFill>
-                <a:latin typeface="Calibri (MS)"/>
-                <a:ea typeface="Calibri (MS)"/>
-                <a:cs typeface="Calibri (MS)"/>
-                <a:sym typeface="Calibri (MS)"/>
-              </a:rPr>
-              <a:t>aplicação</a:t>
-            </a:r>
-            <a:r>
-              <a:rPr lang="en-US" sz="2499" dirty="0">
-                <a:solidFill>
-                  <a:srgbClr val="000000"/>
-                </a:solidFill>
-                <a:latin typeface="Calibri (MS)"/>
-                <a:ea typeface="Calibri (MS)"/>
-                <a:cs typeface="Calibri (MS)"/>
-                <a:sym typeface="Calibri (MS)"/>
-              </a:rPr>
-              <a:t> </a:t>
-            </a:r>
-            <a:r>
-              <a:rPr lang="en-US" sz="2499" dirty="0" err="1">
-                <a:solidFill>
-                  <a:srgbClr val="000000"/>
-                </a:solidFill>
-                <a:latin typeface="Calibri (MS)"/>
-                <a:ea typeface="Calibri (MS)"/>
-                <a:cs typeface="Calibri (MS)"/>
-                <a:sym typeface="Calibri (MS)"/>
-              </a:rPr>
-              <a:t>MindMove</a:t>
-            </a:r>
-            <a:r>
-              <a:rPr lang="en-US" sz="2499" dirty="0">
-                <a:solidFill>
-                  <a:srgbClr val="000000"/>
-                </a:solidFill>
-                <a:latin typeface="Calibri (MS)"/>
-                <a:ea typeface="Calibri (MS)"/>
-                <a:cs typeface="Calibri (MS)"/>
-                <a:sym typeface="Calibri (MS)"/>
-              </a:rPr>
-              <a:t> com </a:t>
-            </a:r>
-            <a:r>
-              <a:rPr lang="en-US" sz="2499" dirty="0" err="1">
-                <a:solidFill>
-                  <a:srgbClr val="000000"/>
-                </a:solidFill>
-                <a:latin typeface="Calibri (MS)"/>
-                <a:ea typeface="Calibri (MS)"/>
-                <a:cs typeface="Calibri (MS)"/>
-                <a:sym typeface="Calibri (MS)"/>
-              </a:rPr>
-              <a:t>monitorização</a:t>
-            </a:r>
-            <a:r>
-              <a:rPr lang="en-US" sz="2499" dirty="0">
-                <a:solidFill>
-                  <a:srgbClr val="000000"/>
-                </a:solidFill>
-                <a:latin typeface="Calibri (MS)"/>
-                <a:ea typeface="Calibri (MS)"/>
-                <a:cs typeface="Calibri (MS)"/>
-                <a:sym typeface="Calibri (MS)"/>
-              </a:rPr>
-              <a:t>, </a:t>
-            </a:r>
-            <a:r>
-              <a:rPr lang="en-US" sz="2499" dirty="0" err="1">
-                <a:solidFill>
-                  <a:srgbClr val="000000"/>
-                </a:solidFill>
-                <a:latin typeface="Calibri (MS)"/>
-                <a:ea typeface="Calibri (MS)"/>
-                <a:cs typeface="Calibri (MS)"/>
-                <a:sym typeface="Calibri (MS)"/>
-              </a:rPr>
-              <a:t>alertas</a:t>
-            </a:r>
-            <a:r>
-              <a:rPr lang="en-US" sz="2499" dirty="0">
-                <a:solidFill>
-                  <a:srgbClr val="000000"/>
-                </a:solidFill>
-                <a:latin typeface="Calibri (MS)"/>
-                <a:ea typeface="Calibri (MS)"/>
-                <a:cs typeface="Calibri (MS)"/>
-                <a:sym typeface="Calibri (MS)"/>
-              </a:rPr>
-              <a:t> e </a:t>
-            </a:r>
-            <a:r>
-              <a:rPr lang="en-US" sz="2499" dirty="0" err="1">
-                <a:solidFill>
-                  <a:srgbClr val="000000"/>
-                </a:solidFill>
-                <a:latin typeface="Calibri (MS)"/>
-                <a:ea typeface="Calibri (MS)"/>
-                <a:cs typeface="Calibri (MS)"/>
-                <a:sym typeface="Calibri (MS)"/>
-              </a:rPr>
-              <a:t>conteúdo</a:t>
-            </a:r>
-            <a:r>
-              <a:rPr lang="en-US" sz="2499" dirty="0">
-                <a:solidFill>
-                  <a:srgbClr val="000000"/>
-                </a:solidFill>
-                <a:latin typeface="Calibri (MS)"/>
-                <a:ea typeface="Calibri (MS)"/>
-                <a:cs typeface="Calibri (MS)"/>
-                <a:sym typeface="Calibri (MS)"/>
-              </a:rPr>
-              <a:t> </a:t>
-            </a:r>
-            <a:r>
-              <a:rPr lang="en-US" sz="2499" dirty="0" err="1">
-                <a:solidFill>
-                  <a:srgbClr val="000000"/>
-                </a:solidFill>
-                <a:latin typeface="Calibri (MS)"/>
-                <a:ea typeface="Calibri (MS)"/>
-                <a:cs typeface="Calibri (MS)"/>
-                <a:sym typeface="Calibri (MS)"/>
-              </a:rPr>
-              <a:t>educativo</a:t>
-            </a:r>
-            <a:r>
-              <a:rPr lang="en-US" sz="2499" dirty="0">
-                <a:solidFill>
-                  <a:srgbClr val="000000"/>
-                </a:solidFill>
-                <a:latin typeface="Calibri (MS)"/>
-                <a:ea typeface="Calibri (MS)"/>
-                <a:cs typeface="Calibri (MS)"/>
-                <a:sym typeface="Calibri (MS)"/>
-              </a:rPr>
-              <a:t>.</a:t>
+              <a:t> 1:1. </a:t>
             </a:r>
           </a:p>
           <a:p>
@@ -11612,6 +11411,257 @@
                 <a:cs typeface="Calibri (MS)"/>
                 <a:sym typeface="Calibri (MS)"/>
               </a:rPr>
+              <a:t>intervenção</a:t>
+            </a:r>
+            <a:r>
+              <a:rPr lang="en-US" sz="2499" dirty="0">
+                <a:solidFill>
+                  <a:srgbClr val="000000"/>
+                </a:solidFill>
+                <a:latin typeface="Calibri (MS)"/>
+                <a:ea typeface="Calibri (MS)"/>
+                <a:cs typeface="Calibri (MS)"/>
+                <a:sym typeface="Calibri (MS)"/>
+              </a:rPr>
+              <a:t> </a:t>
+            </a:r>
+            <a:r>
+              <a:rPr lang="en-US" sz="2499" dirty="0" err="1">
+                <a:solidFill>
+                  <a:srgbClr val="000000"/>
+                </a:solidFill>
+                <a:latin typeface="Calibri (MS)"/>
+                <a:ea typeface="Calibri (MS)"/>
+                <a:cs typeface="Calibri (MS)"/>
+                <a:sym typeface="Calibri (MS)"/>
+              </a:rPr>
+              <a:t>utiliza</a:t>
+            </a:r>
+            <a:r>
+              <a:rPr lang="en-US" sz="2499" dirty="0">
+                <a:solidFill>
+                  <a:srgbClr val="000000"/>
+                </a:solidFill>
+                <a:latin typeface="Calibri (MS)"/>
+                <a:ea typeface="Calibri (MS)"/>
+                <a:cs typeface="Calibri (MS)"/>
+                <a:sym typeface="Calibri (MS)"/>
+              </a:rPr>
+              <a:t> a </a:t>
+            </a:r>
+            <a:r>
+              <a:rPr lang="en-US" sz="2499" dirty="0" err="1">
+                <a:solidFill>
+                  <a:srgbClr val="000000"/>
+                </a:solidFill>
+                <a:latin typeface="Calibri (MS)"/>
+                <a:ea typeface="Calibri (MS)"/>
+                <a:cs typeface="Calibri (MS)"/>
+                <a:sym typeface="Calibri (MS)"/>
+              </a:rPr>
+              <a:t>aplicação</a:t>
+            </a:r>
+            <a:r>
+              <a:rPr lang="en-US" sz="2499" dirty="0">
+                <a:solidFill>
+                  <a:srgbClr val="000000"/>
+                </a:solidFill>
+                <a:latin typeface="Calibri (MS)"/>
+                <a:ea typeface="Calibri (MS)"/>
+                <a:cs typeface="Calibri (MS)"/>
+                <a:sym typeface="Calibri (MS)"/>
+              </a:rPr>
+              <a:t> </a:t>
+            </a:r>
+            <a:r>
+              <a:rPr lang="en-US" sz="2499" dirty="0" err="1">
+                <a:solidFill>
+                  <a:srgbClr val="000000"/>
+                </a:solidFill>
+                <a:latin typeface="Calibri (MS)"/>
+                <a:ea typeface="Calibri (MS)"/>
+                <a:cs typeface="Calibri (MS)"/>
+                <a:sym typeface="Calibri (MS)"/>
+              </a:rPr>
+              <a:t>MindMove</a:t>
+            </a:r>
+            <a:r>
+              <a:rPr lang="en-US" sz="2499" dirty="0">
+                <a:solidFill>
+                  <a:srgbClr val="000000"/>
+                </a:solidFill>
+                <a:latin typeface="Calibri (MS)"/>
+                <a:ea typeface="Calibri (MS)"/>
+                <a:cs typeface="Calibri (MS)"/>
+                <a:sym typeface="Calibri (MS)"/>
+              </a:rPr>
+              <a:t> com </a:t>
+            </a:r>
+            <a:r>
+              <a:rPr lang="en-US" sz="2499" dirty="0" err="1">
+                <a:solidFill>
+                  <a:srgbClr val="000000"/>
+                </a:solidFill>
+                <a:latin typeface="Calibri (MS)"/>
+                <a:ea typeface="Calibri (MS)"/>
+                <a:cs typeface="Calibri (MS)"/>
+                <a:sym typeface="Calibri (MS)"/>
+              </a:rPr>
+              <a:t>monitorização</a:t>
+            </a:r>
+            <a:r>
+              <a:rPr lang="en-US" sz="2499" dirty="0">
+                <a:solidFill>
+                  <a:srgbClr val="000000"/>
+                </a:solidFill>
+                <a:latin typeface="Calibri (MS)"/>
+                <a:ea typeface="Calibri (MS)"/>
+                <a:cs typeface="Calibri (MS)"/>
+                <a:sym typeface="Calibri (MS)"/>
+              </a:rPr>
+              <a:t>, </a:t>
+            </a:r>
+            <a:r>
+              <a:rPr lang="en-US" sz="2499" dirty="0" err="1">
+                <a:solidFill>
+                  <a:srgbClr val="000000"/>
+                </a:solidFill>
+                <a:latin typeface="Calibri (MS)"/>
+                <a:ea typeface="Calibri (MS)"/>
+                <a:cs typeface="Calibri (MS)"/>
+                <a:sym typeface="Calibri (MS)"/>
+              </a:rPr>
+              <a:t>alertas</a:t>
+            </a:r>
+            <a:r>
+              <a:rPr lang="en-US" sz="2499" dirty="0">
+                <a:solidFill>
+                  <a:srgbClr val="000000"/>
+                </a:solidFill>
+                <a:latin typeface="Calibri (MS)"/>
+                <a:ea typeface="Calibri (MS)"/>
+                <a:cs typeface="Calibri (MS)"/>
+                <a:sym typeface="Calibri (MS)"/>
+              </a:rPr>
+              <a:t> e </a:t>
+            </a:r>
+            <a:r>
+              <a:rPr lang="en-US" sz="2499" dirty="0" err="1">
+                <a:solidFill>
+                  <a:srgbClr val="000000"/>
+                </a:solidFill>
+                <a:latin typeface="Calibri (MS)"/>
+                <a:ea typeface="Calibri (MS)"/>
+                <a:cs typeface="Calibri (MS)"/>
+                <a:sym typeface="Calibri (MS)"/>
+              </a:rPr>
+              <a:t>conteúdo</a:t>
+            </a:r>
+            <a:r>
+              <a:rPr lang="en-US" sz="2499" dirty="0">
+                <a:solidFill>
+                  <a:srgbClr val="000000"/>
+                </a:solidFill>
+                <a:latin typeface="Calibri (MS)"/>
+                <a:ea typeface="Calibri (MS)"/>
+                <a:cs typeface="Calibri (MS)"/>
+                <a:sym typeface="Calibri (MS)"/>
+              </a:rPr>
+              <a:t> </a:t>
+            </a:r>
+            <a:r>
+              <a:rPr lang="en-US" sz="2499" dirty="0" err="1">
+                <a:solidFill>
+                  <a:srgbClr val="000000"/>
+                </a:solidFill>
+                <a:latin typeface="Calibri (MS)"/>
+                <a:ea typeface="Calibri (MS)"/>
+                <a:cs typeface="Calibri (MS)"/>
+                <a:sym typeface="Calibri (MS)"/>
+              </a:rPr>
+              <a:t>educativo</a:t>
+            </a:r>
+            <a:r>
+              <a:rPr lang="en-US" sz="2499" dirty="0">
+                <a:solidFill>
+                  <a:srgbClr val="000000"/>
+                </a:solidFill>
+                <a:latin typeface="Calibri (MS)"/>
+                <a:ea typeface="Calibri (MS)"/>
+                <a:cs typeface="Calibri (MS)"/>
+                <a:sym typeface="Calibri (MS)"/>
+              </a:rPr>
+              <a:t>.</a:t>
+            </a:r>
+          </a:p>
+          <a:p>
+            <a:pPr algn="just">
+              <a:lnSpc>
+                <a:spcPct val="150000"/>
+              </a:lnSpc>
+            </a:pPr>
+            <a:endParaRPr lang="en-US" sz="2499" dirty="0">
+              <a:solidFill>
+                <a:srgbClr val="000000"/>
+              </a:solidFill>
+              <a:latin typeface="Calibri (MS)"/>
+              <a:ea typeface="Calibri (MS)"/>
+              <a:cs typeface="Calibri (MS)"/>
+              <a:sym typeface="Calibri (MS)"/>
+            </a:endParaRPr>
+          </a:p>
+          <a:p>
+            <a:pPr algn="just">
+              <a:lnSpc>
+                <a:spcPct val="150000"/>
+              </a:lnSpc>
+            </a:pPr>
+            <a:r>
+              <a:rPr lang="en-US" sz="2499" dirty="0">
+                <a:solidFill>
+                  <a:srgbClr val="000000"/>
+                </a:solidFill>
+                <a:latin typeface="Calibri (MS)"/>
+                <a:ea typeface="Calibri (MS)"/>
+                <a:cs typeface="Calibri (MS)"/>
+                <a:sym typeface="Calibri (MS)"/>
+              </a:rPr>
+              <a:t>O </a:t>
+            </a:r>
+            <a:r>
+              <a:rPr lang="en-US" sz="2499" dirty="0" err="1">
+                <a:solidFill>
+                  <a:srgbClr val="000000"/>
+                </a:solidFill>
+                <a:latin typeface="Calibri (MS)"/>
+                <a:ea typeface="Calibri (MS)"/>
+                <a:cs typeface="Calibri (MS)"/>
+                <a:sym typeface="Calibri (MS)"/>
+              </a:rPr>
+              <a:t>grupo</a:t>
+            </a:r>
+            <a:r>
+              <a:rPr lang="en-US" sz="2499" dirty="0">
+                <a:solidFill>
+                  <a:srgbClr val="000000"/>
+                </a:solidFill>
+                <a:latin typeface="Calibri (MS)"/>
+                <a:ea typeface="Calibri (MS)"/>
+                <a:cs typeface="Calibri (MS)"/>
+                <a:sym typeface="Calibri (MS)"/>
+              </a:rPr>
+              <a:t> </a:t>
+            </a:r>
+            <a:r>
+              <a:rPr lang="en-US" sz="2499" dirty="0" err="1">
+                <a:solidFill>
+                  <a:srgbClr val="000000"/>
+                </a:solidFill>
+                <a:latin typeface="Calibri (MS)"/>
+                <a:ea typeface="Calibri (MS)"/>
+                <a:cs typeface="Calibri (MS)"/>
+                <a:sym typeface="Calibri (MS)"/>
+              </a:rPr>
               <a:t>controlo</a:t>
             </a:r>
             <a:r>
@@ -11793,126 +11843,6 @@
                 <a:sym typeface="Calibri (MS)"/>
               </a:rPr>
               <a:t>). </a:t>
-            </a:r>
-            <a:r>
-              <a:rPr lang="en-US" sz="2499" dirty="0" err="1">
-                <a:solidFill>
-                  <a:srgbClr val="000000"/>
-                </a:solidFill>
-                <a:latin typeface="Calibri (MS)"/>
-                <a:ea typeface="Calibri (MS)"/>
-                <a:cs typeface="Calibri (MS)"/>
-                <a:sym typeface="Calibri (MS)"/>
-              </a:rPr>
-              <a:t>Período</a:t>
-            </a:r>
-            <a:r>
-              <a:rPr lang="en-US" sz="2499" dirty="0">
-                <a:solidFill>
-                  <a:srgbClr val="000000"/>
-                </a:solidFill>
-                <a:latin typeface="Calibri (MS)"/>
-                <a:ea typeface="Calibri (MS)"/>
-                <a:cs typeface="Calibri (MS)"/>
-                <a:sym typeface="Calibri (MS)"/>
-              </a:rPr>
-              <a:t> do </a:t>
-            </a:r>
-            <a:r>
-              <a:rPr lang="en-US" sz="2499" dirty="0" err="1">
-                <a:solidFill>
-                  <a:srgbClr val="000000"/>
-                </a:solidFill>
-                <a:latin typeface="Calibri (MS)"/>
-                <a:ea typeface="Calibri (MS)"/>
-                <a:cs typeface="Calibri (MS)"/>
-                <a:sym typeface="Calibri (MS)"/>
-              </a:rPr>
-              <a:t>estudo</a:t>
-            </a:r>
-            <a:r>
-              <a:rPr lang="en-US" sz="2499" dirty="0">
-                <a:solidFill>
-                  <a:srgbClr val="000000"/>
-                </a:solidFill>
-                <a:latin typeface="Calibri (MS)"/>
-                <a:ea typeface="Calibri (MS)"/>
-                <a:cs typeface="Calibri (MS)"/>
-                <a:sym typeface="Calibri (MS)"/>
-              </a:rPr>
-              <a:t>: 21 a 27 de </a:t>
-            </a:r>
-            <a:r>
-              <a:rPr lang="en-US" sz="2499" dirty="0" err="1">
-                <a:solidFill>
-                  <a:srgbClr val="000000"/>
-                </a:solidFill>
-                <a:latin typeface="Calibri (MS)"/>
-                <a:ea typeface="Calibri (MS)"/>
-                <a:cs typeface="Calibri (MS)"/>
-                <a:sym typeface="Calibri (MS)"/>
-              </a:rPr>
-              <a:t>março</a:t>
-            </a:r>
-            <a:r>
-              <a:rPr lang="en-US" sz="2499" dirty="0">
-                <a:solidFill>
-                  <a:srgbClr val="000000"/>
-                </a:solidFill>
-                <a:latin typeface="Calibri (MS)"/>
-                <a:ea typeface="Calibri (MS)"/>
-                <a:cs typeface="Calibri (MS)"/>
-                <a:sym typeface="Calibri (MS)"/>
-              </a:rPr>
-              <a:t> de 2026 (</a:t>
-            </a:r>
-            <a:r>
-              <a:rPr lang="en-US" sz="2499" dirty="0" err="1">
-                <a:solidFill>
-                  <a:srgbClr val="000000"/>
-                </a:solidFill>
-                <a:latin typeface="Calibri (MS)"/>
-                <a:ea typeface="Calibri (MS)"/>
-                <a:cs typeface="Calibri (MS)"/>
-                <a:sym typeface="Calibri (MS)"/>
-              </a:rPr>
-              <a:t>fase</a:t>
-            </a:r>
-            <a:r>
-              <a:rPr lang="en-US" sz="2499" dirty="0">
-                <a:solidFill>
-                  <a:srgbClr val="000000"/>
-                </a:solidFill>
-                <a:latin typeface="Calibri (MS)"/>
-                <a:ea typeface="Calibri (MS)"/>
-                <a:cs typeface="Calibri (MS)"/>
-                <a:sym typeface="Calibri (MS)"/>
-              </a:rPr>
-              <a:t> </a:t>
-            </a:r>
-            <a:r>
-              <a:rPr lang="en-US" sz="2499" dirty="0" err="1">
-                <a:solidFill>
-                  <a:srgbClr val="000000"/>
-                </a:solidFill>
-                <a:latin typeface="Calibri (MS)"/>
-                <a:ea typeface="Calibri (MS)"/>
-                <a:cs typeface="Calibri (MS)"/>
-                <a:sym typeface="Calibri (MS)"/>
-              </a:rPr>
-              <a:t>piloto</a:t>
-            </a:r>
-            <a:r>
-              <a:rPr lang="en-US" sz="2499" dirty="0">
-                <a:solidFill>
-                  <a:srgbClr val="000000"/>
-                </a:solidFill>
-                <a:latin typeface="Calibri (MS)"/>
-                <a:ea typeface="Calibri (MS)"/>
-                <a:cs typeface="Calibri (MS)"/>
-                <a:sym typeface="Calibri (MS)"/>
-              </a:rPr>
-              <a:t>).</a:t>
             </a:r>
           </a:p>
           <a:p>

</xml_diff>